<commit_message>
feat: align lesson kit and trainer
</commit_message>
<xml_diff>
--- a/methodical-development/Presentation_TuringTrainer_5_minutes_methodical_v3.pptx
+++ b/methodical-development/Presentation_TuringTrainer_5_minutes_methodical_v3.pptx
@@ -2,21 +2,21 @@
 <file path=ppt/presentation.xml><?xml version="1.0" encoding="utf-8"?>
 <p:presentation xmlns:p="http://schemas.openxmlformats.org/presentationml/2006/main">
   <p:sldMasterIdLst>
-    <p:sldMasterId xmlns:r="http://schemas.openxmlformats.org/officeDocument/2006/relationships" id="2147483648" r:id="Ra6e6a8ce4e8146a8"/>
+    <p:sldMasterId xmlns:r="http://schemas.openxmlformats.org/officeDocument/2006/relationships" id="2147483648" r:id="Rc6db497240214efd"/>
   </p:sldMasterIdLst>
   <p:notesMasterIdLst>
-    <p:notesMasterId xmlns:r="http://schemas.openxmlformats.org/officeDocument/2006/relationships" r:id="Raed5f081016b40a5"/>
+    <p:notesMasterId xmlns:r="http://schemas.openxmlformats.org/officeDocument/2006/relationships" r:id="Rd70105930f004ed7"/>
   </p:notesMasterIdLst>
   <p:sldIdLst>
-    <p:sldId xmlns:r="http://schemas.openxmlformats.org/officeDocument/2006/relationships" id="256" r:id="R6a2f857e39714200"/>
-    <p:sldId xmlns:r="http://schemas.openxmlformats.org/officeDocument/2006/relationships" id="257" r:id="Ref60edb0b74443d8"/>
-    <p:sldId xmlns:r="http://schemas.openxmlformats.org/officeDocument/2006/relationships" id="258" r:id="R76f95fcdd3d6464a"/>
-    <p:sldId xmlns:r="http://schemas.openxmlformats.org/officeDocument/2006/relationships" id="259" r:id="R31de971ab9054e54"/>
-    <p:sldId xmlns:r="http://schemas.openxmlformats.org/officeDocument/2006/relationships" id="260" r:id="R141bcc35a9e242bf"/>
-    <p:sldId xmlns:r="http://schemas.openxmlformats.org/officeDocument/2006/relationships" id="261" r:id="Rdfba46ca8dff43de"/>
-    <p:sldId xmlns:r="http://schemas.openxmlformats.org/officeDocument/2006/relationships" id="262" r:id="Rca85b9e8939c469e"/>
-    <p:sldId xmlns:r="http://schemas.openxmlformats.org/officeDocument/2006/relationships" id="263" r:id="Rce357b9f3e55472c"/>
-    <p:sldId xmlns:r="http://schemas.openxmlformats.org/officeDocument/2006/relationships" id="264" r:id="R43cd0a5ddb5540af"/>
+    <p:sldId xmlns:r="http://schemas.openxmlformats.org/officeDocument/2006/relationships" id="256" r:id="R59c82c7afa7049ba"/>
+    <p:sldId xmlns:r="http://schemas.openxmlformats.org/officeDocument/2006/relationships" id="257" r:id="Rb4c5607a5d5746f2"/>
+    <p:sldId xmlns:r="http://schemas.openxmlformats.org/officeDocument/2006/relationships" id="258" r:id="Raaa6e97207b5442d"/>
+    <p:sldId xmlns:r="http://schemas.openxmlformats.org/officeDocument/2006/relationships" id="259" r:id="R59171ce552af4da6"/>
+    <p:sldId xmlns:r="http://schemas.openxmlformats.org/officeDocument/2006/relationships" id="260" r:id="R3266c8f437b34364"/>
+    <p:sldId xmlns:r="http://schemas.openxmlformats.org/officeDocument/2006/relationships" id="261" r:id="R69a2e1e06c9c481f"/>
+    <p:sldId xmlns:r="http://schemas.openxmlformats.org/officeDocument/2006/relationships" id="262" r:id="Rc286ef39d5ae4a30"/>
+    <p:sldId xmlns:r="http://schemas.openxmlformats.org/officeDocument/2006/relationships" id="263" r:id="R0469df1c65834a06"/>
+    <p:sldId xmlns:r="http://schemas.openxmlformats.org/officeDocument/2006/relationships" id="264" r:id="R6dbc0838c924470e"/>
   </p:sldIdLst>
   <p:sldSz cx="12192000" cy="6858000"/>
   <p:notesSz cx="6858000" cy="9144000"/>
@@ -1559,7 +1559,7 @@
   </p:cSld>
   <p:clrMap bg1="lt1" tx1="dk1" bg2="dk2" tx2="lt2" accent1="accent1" accent2="accent2" accent3="accent3" accent4="accent4" accent5="accent5" accent6="accent6" hlink="hlink" folHlink="folHlink"/>
   <p:sldLayoutIdLst>
-    <p:sldLayoutId xmlns:r="http://schemas.openxmlformats.org/officeDocument/2006/relationships" id="2147483649" r:id="Rd87b28162d304619"/>
+    <p:sldLayoutId xmlns:r="http://schemas.openxmlformats.org/officeDocument/2006/relationships" id="2147483649" r:id="Rbf47144567bd47c7"/>
   </p:sldLayoutIdLst>
   <p:hf sldNum="0" hdr="0" ftr="0" dt="0"/>
   <p:txStyles>
@@ -2510,7 +2510,7 @@
           <p:nvPr/>
         </p:nvPicPr>
         <p:blipFill rotWithShape="1">
-          <a:blip xmlns:r="http://schemas.openxmlformats.org/officeDocument/2006/relationships" xmlns:a="http://schemas.openxmlformats.org/drawingml/2006/main" r:embed="R5a4c2b8d71244dfa">
+          <a:blip xmlns:r="http://schemas.openxmlformats.org/officeDocument/2006/relationships" xmlns:a="http://schemas.openxmlformats.org/drawingml/2006/main" r:embed="R6ddea0adc5e545dc">
             <a:alphaModFix/>
           </a:blip>
           <a:srcRect xmlns:a="http://schemas.openxmlformats.org/drawingml/2006/main" l="0" t="0" r="0" b="0"/>
@@ -2792,7 +2792,7 @@
           <p:nvPr/>
         </p:nvPicPr>
         <p:blipFill rotWithShape="1">
-          <a:blip xmlns:r="http://schemas.openxmlformats.org/officeDocument/2006/relationships" xmlns:a="http://schemas.openxmlformats.org/drawingml/2006/main" r:embed="R1f3d6cfa209d4710">
+          <a:blip xmlns:r="http://schemas.openxmlformats.org/officeDocument/2006/relationships" xmlns:a="http://schemas.openxmlformats.org/drawingml/2006/main" r:embed="R3f063a66b4234a1e">
             <a:alphaModFix/>
           </a:blip>
           <a:srcRect xmlns:a="http://schemas.openxmlformats.org/drawingml/2006/main" l="0" t="0" r="0" b="0"/>
@@ -4131,7 +4131,7 @@
           <p:nvPr/>
         </p:nvPicPr>
         <p:blipFill rotWithShape="1">
-          <a:blip xmlns:r="http://schemas.openxmlformats.org/officeDocument/2006/relationships" xmlns:a="http://schemas.openxmlformats.org/drawingml/2006/main" r:embed="R72e370473a0040c3">
+          <a:blip xmlns:r="http://schemas.openxmlformats.org/officeDocument/2006/relationships" xmlns:a="http://schemas.openxmlformats.org/drawingml/2006/main" r:embed="Rbdec84371a7b41fe">
             <a:alphaModFix/>
           </a:blip>
           <a:srcRect xmlns:a="http://schemas.openxmlformats.org/drawingml/2006/main" l="0" t="0" r="0" b="0"/>
@@ -4950,7 +4950,7 @@
           <p:nvPr/>
         </p:nvPicPr>
         <p:blipFill rotWithShape="1">
-          <a:blip xmlns:r="http://schemas.openxmlformats.org/officeDocument/2006/relationships" xmlns:a="http://schemas.openxmlformats.org/drawingml/2006/main" r:embed="R7ad5b3284924429c">
+          <a:blip xmlns:r="http://schemas.openxmlformats.org/officeDocument/2006/relationships" xmlns:a="http://schemas.openxmlformats.org/drawingml/2006/main" r:embed="R1301fa8668934e22">
             <a:alphaModFix/>
           </a:blip>
           <a:srcRect xmlns:a="http://schemas.openxmlformats.org/drawingml/2006/main" l="0" t="0" r="0" b="0"/>
@@ -5307,7 +5307,7 @@
         </p:spPr>
         <p:txBody>
           <a:bodyPr xmlns:a="http://schemas.openxmlformats.org/drawingml/2006/main" wrap="square" lIns="0" tIns="0" rIns="0" bIns="0" anchor="ctr">
-            <a:normAutofit fontScale="87500"/>
+            <a:normAutofit fontScale="100000"/>
           </a:bodyPr>
           <a:lstStyle xmlns:a="http://schemas.openxmlformats.org/drawingml/2006/main"/>
           <a:p xmlns:a="http://schemas.openxmlformats.org/drawingml/2006/main">
@@ -5334,7 +5334,7 @@
                 <a:ea typeface="Arial"/>
                 <a:cs typeface="Arial"/>
               </a:rPr>
-              <a:t>Комплект учителя управляет ходом двух уроков: сценарий, диагностические вопросы, дифференциация и резервные решения</a:t>
+              <a:t>Комплект учителя управляет ходом двух уроков: сценарий, карточки пары, резервные решения и ключи</a:t>
             </a:r>
           </a:p>
         </p:txBody>
@@ -6401,7 +6401,7 @@
           <p:nvPr/>
         </p:nvPicPr>
         <p:blipFill rotWithShape="1">
-          <a:blip xmlns:r="http://schemas.openxmlformats.org/officeDocument/2006/relationships" xmlns:a="http://schemas.openxmlformats.org/drawingml/2006/main" r:embed="R17cffc5df3c349f4">
+          <a:blip xmlns:r="http://schemas.openxmlformats.org/officeDocument/2006/relationships" xmlns:a="http://schemas.openxmlformats.org/drawingml/2006/main" r:embed="R5083829e35564613">
             <a:alphaModFix/>
           </a:blip>
           <a:srcRect xmlns:a="http://schemas.openxmlformats.org/drawingml/2006/main" l="0" t="0" r="0" b="0"/>
@@ -7307,7 +7307,7 @@
                 <a:ea typeface="Arial"/>
                 <a:cs typeface="Arial"/>
               </a:rPr>
-              <a:t>Три попытки: время, шаги, подсказки и ошибки</a:t>
+              <a:t>Попытка 1 отдельно; сравнение только попыток 2 и 3</a:t>
             </a:r>
           </a:p>
         </p:txBody>
@@ -7368,7 +7368,7 @@
                 <a:ea typeface="Arial"/>
                 <a:cs typeface="Arial"/>
               </a:rPr>
-              <a:t>Тренажёр + рабочий лист</a:t>
+              <a:t>Карточки + рабочий лист</a:t>
             </a:r>
           </a:p>
         </p:txBody>
@@ -8575,7 +8575,7 @@
           <p:nvPr/>
         </p:nvPicPr>
         <p:blipFill rotWithShape="1">
-          <a:blip xmlns:r="http://schemas.openxmlformats.org/officeDocument/2006/relationships" xmlns:a="http://schemas.openxmlformats.org/drawingml/2006/main" r:embed="Rf7c4b1d4df954b42">
+          <a:blip xmlns:r="http://schemas.openxmlformats.org/officeDocument/2006/relationships" xmlns:a="http://schemas.openxmlformats.org/drawingml/2006/main" r:embed="R8bb69cf55fbf45e3">
             <a:alphaModFix/>
           </a:blip>
           <a:srcRect xmlns:a="http://schemas.openxmlformats.org/drawingml/2006/main" l="0" t="0" r="0" b="0"/>
@@ -8603,7 +8603,7 @@
           <p:nvPr/>
         </p:nvPicPr>
         <p:blipFill>
-          <a:blip xmlns:r="http://schemas.openxmlformats.org/officeDocument/2006/relationships" xmlns:a="http://schemas.openxmlformats.org/drawingml/2006/main" r:embed="R6802ac37e6ff443b"/>
+          <a:blip xmlns:r="http://schemas.openxmlformats.org/officeDocument/2006/relationships" xmlns:a="http://schemas.openxmlformats.org/drawingml/2006/main" r:embed="R4869c695a5684fa9"/>
           <a:srcRect xmlns:a="http://schemas.openxmlformats.org/drawingml/2006/main" l="0" t="17402" r="0" b="17402"/>
           <a:stretch xmlns:a="http://schemas.openxmlformats.org/drawingml/2006/main">
             <a:fillRect l="0" t="0" r="0" b="0"/>
@@ -10027,7 +10027,7 @@
           <p:nvPr/>
         </p:nvPicPr>
         <p:blipFill rotWithShape="1">
-          <a:blip xmlns:r="http://schemas.openxmlformats.org/officeDocument/2006/relationships" xmlns:a="http://schemas.openxmlformats.org/drawingml/2006/main" r:embed="Rb11ae715ad3c4534">
+          <a:blip xmlns:r="http://schemas.openxmlformats.org/officeDocument/2006/relationships" xmlns:a="http://schemas.openxmlformats.org/drawingml/2006/main" r:embed="R7f2b0fbb923d428d">
             <a:alphaModFix/>
           </a:blip>
           <a:srcRect xmlns:a="http://schemas.openxmlformats.org/drawingml/2006/main" l="0" t="0" r="0" b="0"/>
@@ -11867,7 +11867,7 @@
                 <a:ea typeface="Arial"/>
                 <a:cs typeface="Arial"/>
               </a:rPr>
-              <a:t>Дополнительно: не менее двух найденных ошибок из трёх; каждый использованный ответ ИИ проверен</a:t>
+              <a:t>Обязательные условия принятия важнее суммы; ИИ проверяется только при использовании</a:t>
             </a:r>
           </a:p>
         </p:txBody>
@@ -11903,7 +11903,7 @@
           <p:nvPr/>
         </p:nvPicPr>
         <p:blipFill rotWithShape="1">
-          <a:blip xmlns:r="http://schemas.openxmlformats.org/officeDocument/2006/relationships" xmlns:a="http://schemas.openxmlformats.org/drawingml/2006/main" r:embed="Rf7276d7c5fa546a6">
+          <a:blip xmlns:r="http://schemas.openxmlformats.org/officeDocument/2006/relationships" xmlns:a="http://schemas.openxmlformats.org/drawingml/2006/main" r:embed="R8689192559a14366">
             <a:alphaModFix/>
           </a:blip>
           <a:srcRect xmlns:a="http://schemas.openxmlformats.org/drawingml/2006/main" l="0" t="0" r="0" b="0"/>
@@ -12626,7 +12626,7 @@
                 <a:ea typeface="Arial"/>
                 <a:cs typeface="Arial"/>
               </a:rPr>
-              <a:t>Проектное задание</a:t>
+              <a:t>Карточки и резерв</a:t>
             </a:r>
           </a:p>
         </p:txBody>
@@ -12687,7 +12687,7 @@
                 <a:ea typeface="Arial"/>
                 <a:cs typeface="Arial"/>
               </a:rPr>
-              <a:t>Роль команды, заказчик, продукт и критерии</a:t>
+              <a:t>Назначение пары, ключи и работа без компьютера</a:t>
             </a:r>
           </a:p>
         </p:txBody>
@@ -12935,7 +12935,7 @@
                 <a:ea typeface="Arial"/>
                 <a:cs typeface="Arial"/>
               </a:rPr>
-              <a:t>Протокол стратегий, попыток, ошибок и проверки ИИ</a:t>
+              <a:t>Свободная попытка, контролируемая пара и выводы</a:t>
             </a:r>
           </a:p>
         </p:txBody>
@@ -13122,7 +13122,7 @@
                 <a:ea typeface="Arial"/>
                 <a:cs typeface="Arial"/>
               </a:rPr>
-              <a:t>Шаблон маршрута</a:t>
+              <a:t>Шаблон и образец маршрута</a:t>
             </a:r>
           </a:p>
         </p:txBody>
@@ -13183,7 +13183,7 @@
                 <a:ea typeface="Arial"/>
                 <a:cs typeface="Arial"/>
               </a:rPr>
-              <a:t>Готовая форма итогового ученического продукта</a:t>
+              <a:t>Пустая форма и заполненный демонстрационный пример</a:t>
             </a:r>
           </a:p>
         </p:txBody>
@@ -13431,7 +13431,7 @@
                 <a:ea typeface="Arial"/>
                 <a:cs typeface="Arial"/>
               </a:rPr>
-              <a:t>Входной тест, кейс, итоговые варианты и ключи</a:t>
+              <a:t>Трёхсостоянийные итоговые варианты и ключи</a:t>
             </a:r>
           </a:p>
         </p:txBody>
@@ -13679,7 +13679,7 @@
                 <a:ea typeface="Arial"/>
                 <a:cs typeface="Arial"/>
               </a:rPr>
-              <a:t>Пять критериев, ограничения балла и лист экспертизы</a:t>
+              <a:t>Пять критериев и обязательные условия принятия</a:t>
             </a:r>
           </a:p>
         </p:txBody>
@@ -13897,7 +13897,7 @@
                 <a:ea typeface="Arial"/>
                 <a:cs typeface="Arial"/>
               </a:rPr>
-              <a:t>Автономно: один HTML-файл</a:t>
+              <a:t>Автономно: HTML + папка материалов</a:t>
             </a:r>
           </a:p>
         </p:txBody>
@@ -14001,7 +14001,7 @@
           <p:nvPr/>
         </p:nvPicPr>
         <p:blipFill rotWithShape="1">
-          <a:blip xmlns:r="http://schemas.openxmlformats.org/officeDocument/2006/relationships" xmlns:a="http://schemas.openxmlformats.org/drawingml/2006/main" r:embed="R93cddbb420e14ab0">
+          <a:blip xmlns:r="http://schemas.openxmlformats.org/officeDocument/2006/relationships" xmlns:a="http://schemas.openxmlformats.org/drawingml/2006/main" r:embed="R76b769fd7bef4dc6">
             <a:alphaModFix/>
           </a:blip>
           <a:srcRect xmlns:a="http://schemas.openxmlformats.org/drawingml/2006/main" l="0" t="0" r="0" b="0"/>
@@ -14164,7 +14164,7 @@
                 <a:ea typeface="Arial"/>
                 <a:cs typeface="Arial"/>
               </a:rPr>
-              <a:t>Сценарий, материалы ученика, диагностика и оценивание связаны в один комплект</a:t>
+              <a:t>Сценарий, задания, резерв, диагностика и оценивание согласованы между собой</a:t>
             </a:r>
           </a:p>
         </p:txBody>

</xml_diff>